<commit_message>
Finalize submission with recorded video link, screenshots and Git evidence
</commit_message>
<xml_diff>
--- a/submission/POS_Presentation.pptx
+++ b/submission/POS_Presentation.pptx
@@ -981,7 +981,7 @@
           <a:lstStyle/>
           <a:p>
             <a:r>
-              <a:t>Current project is an individual submission. Confirm the instructor accepts this. The remote repository was created by the student. Actual upload and video evidence must be completed and verified. Do not claim recorded sprint history.</a:t>
+              <a:t>Completed presentation and source material. Video URL: https://www.bilibili.com/video/BV1xgnp64E3X/. The repository retains the personal branch merged into main. The proposed sprint plan is not a claim of recorded daily sprint activity. Future work includes authentication, printing and electronic payments.</a:t>
             </a:r>
           </a:p>
         </p:txBody>
@@ -5880,7 +5880,7 @@
               </a:defRPr>
             </a:pPr>
             <a:r>
-              <a:t>Report, UML, source, tests, slides and quiz answers are supplied.</a:t>
+              <a:t>Report, UML, source, tests and quiz answers are complete.</a:t>
             </a:r>
           </a:p>
           <a:p>
@@ -5896,7 +5896,7 @@
               </a:defRPr>
             </a:pPr>
             <a:r>
-              <a:t>Keep real Git branches and capture command-history evidence.</a:t>
+              <a:t>Cash sales, returns and automated tests are demonstrated.</a:t>
             </a:r>
           </a:p>
           <a:p>
@@ -5912,7 +5912,7 @@
               </a:defRPr>
             </a:pPr>
             <a:r>
-              <a:t>Record the slide-led demo and upload it to bilibili.</a:t>
+              <a:t>The personal branch is merged into main and retained.</a:t>
             </a:r>
           </a:p>
           <a:p>
@@ -5928,7 +5928,7 @@
               </a:defRPr>
             </a:pPr>
             <a:r>
-              <a:t>Add the final video URL to the report cover.</a:t>
+              <a:t>Video: bilibili.com/video/BV1xgnp64E3X/</a:t>
             </a:r>
           </a:p>
           <a:p>
@@ -5944,7 +5944,7 @@
               </a:defRPr>
             </a:pPr>
             <a:r>
-              <a:t>Future extensions: authenticated cashiers, printers and payment adapters.</a:t>
+              <a:t>Future work: cashier authentication, printers and payment adapters.</a:t>
             </a:r>
           </a:p>
         </p:txBody>

</xml_diff>